<commit_message>
Remove security deposit reference from approach and methodology slides
Co-Authored-By: Claude Opus 5.5 <noreply@anthropic.com>
Claude-Session: https://claude.ai/code/session_01Suo9gkBTWtUDD7LdnsuAe3
</commit_message>
<xml_diff>
--- a/KTPH_Approach_Methodology.pptx
+++ b/KTPH_Approach_Methodology.pptx
@@ -110,7 +110,7 @@
   <p:extLst>
     <p:ext uri="{521415D9-36F7-43E2-AB2F-B90AF26B5E84}">
       <p14:sectionLst xmlns:p14="http://schemas.microsoft.com/office/powerpoint/2010/main">
-        <p14:section name="4 · Understanding of the project" id="{0ffac0dd-daac-a1e6-6f44-a2aa8cc7e2d5}">
+        <p14:section name="4 · Understanding of the project" id="{54b788be-e8ec-8618-2ddd-68a072fa1e05}">
           <p14:sldIdLst>
             <p14:sldId id="256"/>
             <p14:sldId id="257"/>
@@ -610,7 +610,7 @@
           <a:p>
             <a:r>
               <a:rPr lang="en-US" dirty="0"/>
-              <a:t>Timings marked 'MA' come from the Master Agreement; the 28-day mobilisation comes from the RFP. Durations in teal (survey window, install rate, 4-week hypercare) are MONIT proposals, not contract terms - confirm before submission. Security deposit timing differs (RFP 14 days vs MA Schedule 2 30 days): plan to the shorter.</a:t>
+              <a:t>Timings marked 'MA' come from the Master Agreement; the 28-day mobilisation comes from the RFP. Durations in teal (survey window, install rate, 4-week hypercare) are MONIT proposals, not contract terms - confirm before submission.</a:t>
             </a:r>
             <a:endParaRPr lang="en-US" dirty="0"/>
           </a:p>
@@ -2916,7 +2916,7 @@
                             <a:srgbClr val="1F2937"/>
                           </a:solidFill>
                         </a:rPr>
-                        <a:t>Kick-off with ALPS and the three hospitals; project managers named; security deposit and insurance lodged</a:t>
+                        <a:t>Kick-off with ALPS and the three hospitals; project managers named; insurance in place</a:t>
                       </a:r>
                       <a:endParaRPr lang="en-US" sz="1000" dirty="0"/>
                     </a:p>

</xml_diff>